<commit_message>
Deployed 641336a with MkDocs version: 1.6.1
</commit_message>
<xml_diff>
--- a/resources/graficosBD.pptx
+++ b/resources/graficosBD.pptx
@@ -114,16 +114,48 @@
 </p:presentation>
 </file>
 
-<file path=ppt/revisionInfo.xml><?xml version="1.0" encoding="utf-8"?>
-<p1510:revInfo xmlns:a="http://schemas.openxmlformats.org/drawingml/2006/main" xmlns:r="http://schemas.openxmlformats.org/officeDocument/2006/relationships" xmlns:p1510="http://schemas.microsoft.com/office/powerpoint/2015/10/main">
-  <p1510:revLst>
-    <p1510:client id="{1C1A9418-01FF-EB43-B3B1-3FA2F3B7AF27}" v="4" dt="2024-08-19T15:25:54.264"/>
-  </p1510:revLst>
-</p1510:revInfo>
-</file>
-
 <file path=ppt/changesInfos/changesInfo1.xml><?xml version="1.0" encoding="utf-8"?>
 <pc:chgInfo xmlns:a="http://schemas.openxmlformats.org/drawingml/2006/main" xmlns:r="http://schemas.openxmlformats.org/officeDocument/2006/relationships" xmlns:ac="http://schemas.microsoft.com/office/drawing/2013/main/command" xmlns:pc="http://schemas.microsoft.com/office/powerpoint/2013/main/command">
+  <pc:docChgLst>
+    <pc:chgData name="MEDRANO ESCRIG, AITOR" userId="0d3502aa-7666-4142-bea3-4e942ac6c91d" providerId="ADAL" clId="{F6EAA8F8-23D7-4BC0-BC13-E314CB750E71}"/>
+    <pc:docChg chg="custSel modSld">
+      <pc:chgData name="MEDRANO ESCRIG, AITOR" userId="0d3502aa-7666-4142-bea3-4e942ac6c91d" providerId="ADAL" clId="{F6EAA8F8-23D7-4BC0-BC13-E314CB750E71}" dt="2025-01-27T08:54:13.577" v="2" actId="478"/>
+      <pc:docMkLst>
+        <pc:docMk/>
+      </pc:docMkLst>
+      <pc:sldChg chg="addSp delSp modSp mod">
+        <pc:chgData name="MEDRANO ESCRIG, AITOR" userId="0d3502aa-7666-4142-bea3-4e942ac6c91d" providerId="ADAL" clId="{F6EAA8F8-23D7-4BC0-BC13-E314CB750E71}" dt="2025-01-27T08:54:13.577" v="2" actId="478"/>
+        <pc:sldMkLst>
+          <pc:docMk/>
+          <pc:sldMk cId="1605562311" sldId="261"/>
+        </pc:sldMkLst>
+        <pc:spChg chg="del">
+          <ac:chgData name="MEDRANO ESCRIG, AITOR" userId="0d3502aa-7666-4142-bea3-4e942ac6c91d" providerId="ADAL" clId="{F6EAA8F8-23D7-4BC0-BC13-E314CB750E71}" dt="2025-01-27T08:54:08.056" v="0" actId="478"/>
+          <ac:spMkLst>
+            <pc:docMk/>
+            <pc:sldMk cId="1605562311" sldId="261"/>
+            <ac:spMk id="2" creationId="{B66FD903-9D02-82D8-167A-B7CC666E5357}"/>
+          </ac:spMkLst>
+        </pc:spChg>
+        <pc:spChg chg="del">
+          <ac:chgData name="MEDRANO ESCRIG, AITOR" userId="0d3502aa-7666-4142-bea3-4e942ac6c91d" providerId="ADAL" clId="{F6EAA8F8-23D7-4BC0-BC13-E314CB750E71}" dt="2025-01-27T08:54:10.786" v="1" actId="478"/>
+          <ac:spMkLst>
+            <pc:docMk/>
+            <pc:sldMk cId="1605562311" sldId="261"/>
+            <ac:spMk id="3" creationId="{33EE4142-6A54-96B9-6409-1C787800FAA8}"/>
+          </ac:spMkLst>
+        </pc:spChg>
+        <pc:spChg chg="add del mod">
+          <ac:chgData name="MEDRANO ESCRIG, AITOR" userId="0d3502aa-7666-4142-bea3-4e942ac6c91d" providerId="ADAL" clId="{F6EAA8F8-23D7-4BC0-BC13-E314CB750E71}" dt="2025-01-27T08:54:13.577" v="2" actId="478"/>
+          <ac:spMkLst>
+            <pc:docMk/>
+            <pc:sldMk cId="1605562311" sldId="261"/>
+            <ac:spMk id="5" creationId="{230F044C-F127-7EC3-08C9-2ACE446CA8DE}"/>
+          </ac:spMkLst>
+        </pc:spChg>
+      </pc:sldChg>
+    </pc:docChg>
+  </pc:docChgLst>
   <pc:docChgLst>
     <pc:chgData name="MEDRANO ESCRIG, AITOR" userId="0d3502aa-7666-4142-bea3-4e942ac6c91d" providerId="ADAL" clId="{75DD5463-8147-4F71-B6BC-989CA61CC403}"/>
     <pc:docChg chg="custSel addSld modSld">
@@ -137,126 +169,6 @@
           <pc:docMk/>
           <pc:sldMk cId="1153971177" sldId="257"/>
         </pc:sldMkLst>
-        <pc:spChg chg="mod">
-          <ac:chgData name="MEDRANO ESCRIG, AITOR" userId="0d3502aa-7666-4142-bea3-4e942ac6c91d" providerId="ADAL" clId="{75DD5463-8147-4F71-B6BC-989CA61CC403}" dt="2024-08-08T18:46:30.012" v="73" actId="20577"/>
-          <ac:spMkLst>
-            <pc:docMk/>
-            <pc:sldMk cId="1153971177" sldId="257"/>
-            <ac:spMk id="5" creationId="{AA461F6F-3B2E-CD78-6478-868EAC0898F2}"/>
-          </ac:spMkLst>
-        </pc:spChg>
-        <pc:spChg chg="del">
-          <ac:chgData name="MEDRANO ESCRIG, AITOR" userId="0d3502aa-7666-4142-bea3-4e942ac6c91d" providerId="ADAL" clId="{75DD5463-8147-4F71-B6BC-989CA61CC403}" dt="2024-08-08T18:48:22.475" v="86" actId="478"/>
-          <ac:spMkLst>
-            <pc:docMk/>
-            <pc:sldMk cId="1153971177" sldId="257"/>
-            <ac:spMk id="23" creationId="{8B8BF032-BE9E-0BF7-013A-44C21EA7DA85}"/>
-          </ac:spMkLst>
-        </pc:spChg>
-        <pc:spChg chg="del">
-          <ac:chgData name="MEDRANO ESCRIG, AITOR" userId="0d3502aa-7666-4142-bea3-4e942ac6c91d" providerId="ADAL" clId="{75DD5463-8147-4F71-B6BC-989CA61CC403}" dt="2024-08-08T18:48:20.597" v="85" actId="478"/>
-          <ac:spMkLst>
-            <pc:docMk/>
-            <pc:sldMk cId="1153971177" sldId="257"/>
-            <ac:spMk id="24" creationId="{4AEF133D-4A4B-7B95-3536-EBA491AE30BB}"/>
-          </ac:spMkLst>
-        </pc:spChg>
-        <pc:cxnChg chg="mod">
-          <ac:chgData name="MEDRANO ESCRIG, AITOR" userId="0d3502aa-7666-4142-bea3-4e942ac6c91d" providerId="ADAL" clId="{75DD5463-8147-4F71-B6BC-989CA61CC403}" dt="2024-08-08T18:46:37.350" v="74" actId="14100"/>
-          <ac:cxnSpMkLst>
-            <pc:docMk/>
-            <pc:sldMk cId="1153971177" sldId="257"/>
-            <ac:cxnSpMk id="7" creationId="{F4E49F37-9A66-5295-C6EA-FE3DE78A0CF3}"/>
-          </ac:cxnSpMkLst>
-        </pc:cxnChg>
-        <pc:cxnChg chg="mod">
-          <ac:chgData name="MEDRANO ESCRIG, AITOR" userId="0d3502aa-7666-4142-bea3-4e942ac6c91d" providerId="ADAL" clId="{75DD5463-8147-4F71-B6BC-989CA61CC403}" dt="2024-08-08T18:46:46.905" v="78" actId="14100"/>
-          <ac:cxnSpMkLst>
-            <pc:docMk/>
-            <pc:sldMk cId="1153971177" sldId="257"/>
-            <ac:cxnSpMk id="8" creationId="{EE24E5A2-AA3A-3645-7E1E-979644CE7DF4}"/>
-          </ac:cxnSpMkLst>
-        </pc:cxnChg>
-        <pc:cxnChg chg="add mod">
-          <ac:chgData name="MEDRANO ESCRIG, AITOR" userId="0d3502aa-7666-4142-bea3-4e942ac6c91d" providerId="ADAL" clId="{75DD5463-8147-4F71-B6BC-989CA61CC403}" dt="2024-08-08T18:46:59.578" v="81" actId="14100"/>
-          <ac:cxnSpMkLst>
-            <pc:docMk/>
-            <pc:sldMk cId="1153971177" sldId="257"/>
-            <ac:cxnSpMk id="11" creationId="{E86BBA03-3147-0FEF-7C39-7928AF905B3B}"/>
-          </ac:cxnSpMkLst>
-        </pc:cxnChg>
-        <pc:cxnChg chg="mod">
-          <ac:chgData name="MEDRANO ESCRIG, AITOR" userId="0d3502aa-7666-4142-bea3-4e942ac6c91d" providerId="ADAL" clId="{75DD5463-8147-4F71-B6BC-989CA61CC403}" dt="2024-08-08T18:46:44.436" v="77" actId="14100"/>
-          <ac:cxnSpMkLst>
-            <pc:docMk/>
-            <pc:sldMk cId="1153971177" sldId="257"/>
-            <ac:cxnSpMk id="13" creationId="{9DA8E11B-06D9-C5A5-0417-AB8AD906CB12}"/>
-          </ac:cxnSpMkLst>
-        </pc:cxnChg>
-        <pc:cxnChg chg="add mod">
-          <ac:chgData name="MEDRANO ESCRIG, AITOR" userId="0d3502aa-7666-4142-bea3-4e942ac6c91d" providerId="ADAL" clId="{75DD5463-8147-4F71-B6BC-989CA61CC403}" dt="2024-08-08T18:47:10.703" v="84" actId="14100"/>
-          <ac:cxnSpMkLst>
-            <pc:docMk/>
-            <pc:sldMk cId="1153971177" sldId="257"/>
-            <ac:cxnSpMk id="15" creationId="{D5A244D7-621E-8DEA-5390-5E69E3A51E7F}"/>
-          </ac:cxnSpMkLst>
-        </pc:cxnChg>
-        <pc:cxnChg chg="mod">
-          <ac:chgData name="MEDRANO ESCRIG, AITOR" userId="0d3502aa-7666-4142-bea3-4e942ac6c91d" providerId="ADAL" clId="{75DD5463-8147-4F71-B6BC-989CA61CC403}" dt="2024-08-08T18:46:40.005" v="75" actId="14100"/>
-          <ac:cxnSpMkLst>
-            <pc:docMk/>
-            <pc:sldMk cId="1153971177" sldId="257"/>
-            <ac:cxnSpMk id="16" creationId="{C68A7CF0-428A-404D-809B-6E419B0AE241}"/>
-          </ac:cxnSpMkLst>
-        </pc:cxnChg>
-        <pc:cxnChg chg="mod">
-          <ac:chgData name="MEDRANO ESCRIG, AITOR" userId="0d3502aa-7666-4142-bea3-4e942ac6c91d" providerId="ADAL" clId="{75DD5463-8147-4F71-B6BC-989CA61CC403}" dt="2024-08-08T18:46:42.581" v="76" actId="14100"/>
-          <ac:cxnSpMkLst>
-            <pc:docMk/>
-            <pc:sldMk cId="1153971177" sldId="257"/>
-            <ac:cxnSpMk id="20" creationId="{40D67917-38FA-9550-391B-FA92B7DD0417}"/>
-          </ac:cxnSpMkLst>
-        </pc:cxnChg>
-        <pc:cxnChg chg="del">
-          <ac:chgData name="MEDRANO ESCRIG, AITOR" userId="0d3502aa-7666-4142-bea3-4e942ac6c91d" providerId="ADAL" clId="{75DD5463-8147-4F71-B6BC-989CA61CC403}" dt="2024-08-08T18:48:20.597" v="85" actId="478"/>
-          <ac:cxnSpMkLst>
-            <pc:docMk/>
-            <pc:sldMk cId="1153971177" sldId="257"/>
-            <ac:cxnSpMk id="25" creationId="{8D2D99D5-9BC8-5ED4-5887-22AB227F6A09}"/>
-          </ac:cxnSpMkLst>
-        </pc:cxnChg>
-        <pc:cxnChg chg="del">
-          <ac:chgData name="MEDRANO ESCRIG, AITOR" userId="0d3502aa-7666-4142-bea3-4e942ac6c91d" providerId="ADAL" clId="{75DD5463-8147-4F71-B6BC-989CA61CC403}" dt="2024-08-08T18:48:20.597" v="85" actId="478"/>
-          <ac:cxnSpMkLst>
-            <pc:docMk/>
-            <pc:sldMk cId="1153971177" sldId="257"/>
-            <ac:cxnSpMk id="26" creationId="{ED37823B-4E7D-8EB1-4E1E-658E98FF3159}"/>
-          </ac:cxnSpMkLst>
-        </pc:cxnChg>
-        <pc:cxnChg chg="del">
-          <ac:chgData name="MEDRANO ESCRIG, AITOR" userId="0d3502aa-7666-4142-bea3-4e942ac6c91d" providerId="ADAL" clId="{75DD5463-8147-4F71-B6BC-989CA61CC403}" dt="2024-08-08T18:48:20.597" v="85" actId="478"/>
-          <ac:cxnSpMkLst>
-            <pc:docMk/>
-            <pc:sldMk cId="1153971177" sldId="257"/>
-            <ac:cxnSpMk id="28" creationId="{C299019E-365E-70BA-6D58-3C1344F1493F}"/>
-          </ac:cxnSpMkLst>
-        </pc:cxnChg>
-        <pc:cxnChg chg="del">
-          <ac:chgData name="MEDRANO ESCRIG, AITOR" userId="0d3502aa-7666-4142-bea3-4e942ac6c91d" providerId="ADAL" clId="{75DD5463-8147-4F71-B6BC-989CA61CC403}" dt="2024-08-08T18:48:20.597" v="85" actId="478"/>
-          <ac:cxnSpMkLst>
-            <pc:docMk/>
-            <pc:sldMk cId="1153971177" sldId="257"/>
-            <ac:cxnSpMk id="29" creationId="{86440354-F788-AE7A-B6C5-CBB3B2C5E229}"/>
-          </ac:cxnSpMkLst>
-        </pc:cxnChg>
-        <pc:cxnChg chg="del">
-          <ac:chgData name="MEDRANO ESCRIG, AITOR" userId="0d3502aa-7666-4142-bea3-4e942ac6c91d" providerId="ADAL" clId="{75DD5463-8147-4F71-B6BC-989CA61CC403}" dt="2024-08-08T18:48:20.597" v="85" actId="478"/>
-          <ac:cxnSpMkLst>
-            <pc:docMk/>
-            <pc:sldMk cId="1153971177" sldId="257"/>
-            <ac:cxnSpMk id="33" creationId="{C753CFE3-9B5D-4580-6B9A-BB4E5A6E571F}"/>
-          </ac:cxnSpMkLst>
-        </pc:cxnChg>
       </pc:sldChg>
     </pc:docChg>
   </pc:docChgLst>
@@ -273,22 +185,6 @@
           <pc:docMk/>
           <pc:sldMk cId="3874715286" sldId="258"/>
         </pc:sldMkLst>
-        <pc:spChg chg="add del mod">
-          <ac:chgData name="MEDRANO ESCRIG, AITOR" userId="0d3502aa-7666-4142-bea3-4e942ac6c91d" providerId="ADAL" clId="{1C1A9418-01FF-EB43-B3B1-3FA2F3B7AF27}" dt="2024-08-19T15:26:00.666" v="24" actId="478"/>
-          <ac:spMkLst>
-            <pc:docMk/>
-            <pc:sldMk cId="3874715286" sldId="258"/>
-            <ac:spMk id="3" creationId="{0DEFA389-777A-06DC-DC50-59B475949D3F}"/>
-          </ac:spMkLst>
-        </pc:spChg>
-        <pc:graphicFrameChg chg="add del mod modGraphic">
-          <ac:chgData name="MEDRANO ESCRIG, AITOR" userId="0d3502aa-7666-4142-bea3-4e942ac6c91d" providerId="ADAL" clId="{1C1A9418-01FF-EB43-B3B1-3FA2F3B7AF27}" dt="2024-08-19T15:25:25.876" v="18" actId="478"/>
-          <ac:graphicFrameMkLst>
-            <pc:docMk/>
-            <pc:sldMk cId="3874715286" sldId="258"/>
-            <ac:graphicFrameMk id="2" creationId="{66730958-A737-0166-73B3-A363F722A8DC}"/>
-          </ac:graphicFrameMkLst>
-        </pc:graphicFrameChg>
       </pc:sldChg>
       <pc:sldChg chg="new del">
         <pc:chgData name="MEDRANO ESCRIG, AITOR" userId="0d3502aa-7666-4142-bea3-4e942ac6c91d" providerId="ADAL" clId="{1C1A9418-01FF-EB43-B3B1-3FA2F3B7AF27}" dt="2024-08-19T15:26:02.865" v="25" actId="2696"/>
@@ -303,22 +199,6 @@
           <pc:docMk/>
           <pc:sldMk cId="2836919165" sldId="260"/>
         </pc:sldMkLst>
-        <pc:spChg chg="del">
-          <ac:chgData name="MEDRANO ESCRIG, AITOR" userId="0d3502aa-7666-4142-bea3-4e942ac6c91d" providerId="ADAL" clId="{1C1A9418-01FF-EB43-B3B1-3FA2F3B7AF27}" dt="2024-08-19T15:25:39.870" v="21" actId="21"/>
-          <ac:spMkLst>
-            <pc:docMk/>
-            <pc:sldMk cId="2836919165" sldId="260"/>
-            <ac:spMk id="3" creationId="{034638A6-1463-82A3-0255-72D23868BFA6}"/>
-          </ac:spMkLst>
-        </pc:spChg>
-        <pc:spChg chg="del">
-          <ac:chgData name="MEDRANO ESCRIG, AITOR" userId="0d3502aa-7666-4142-bea3-4e942ac6c91d" providerId="ADAL" clId="{1C1A9418-01FF-EB43-B3B1-3FA2F3B7AF27}" dt="2024-08-19T15:25:44.429" v="22" actId="21"/>
-          <ac:spMkLst>
-            <pc:docMk/>
-            <pc:sldMk cId="2836919165" sldId="260"/>
-            <ac:spMk id="4" creationId="{D66E86FC-7FAE-6890-C9F9-43D0833AEF97}"/>
-          </ac:spMkLst>
-        </pc:spChg>
       </pc:sldChg>
       <pc:sldChg chg="modSp new mod">
         <pc:chgData name="MEDRANO ESCRIG, AITOR" userId="0d3502aa-7666-4142-bea3-4e942ac6c91d" providerId="ADAL" clId="{1C1A9418-01FF-EB43-B3B1-3FA2F3B7AF27}" dt="2024-08-19T15:27:47.324" v="49" actId="20577"/>
@@ -326,14 +206,6 @@
           <pc:docMk/>
           <pc:sldMk cId="1605562311" sldId="261"/>
         </pc:sldMkLst>
-        <pc:spChg chg="mod">
-          <ac:chgData name="MEDRANO ESCRIG, AITOR" userId="0d3502aa-7666-4142-bea3-4e942ac6c91d" providerId="ADAL" clId="{1C1A9418-01FF-EB43-B3B1-3FA2F3B7AF27}" dt="2024-08-19T15:27:47.324" v="49" actId="20577"/>
-          <ac:spMkLst>
-            <pc:docMk/>
-            <pc:sldMk cId="1605562311" sldId="261"/>
-            <ac:spMk id="3" creationId="{33EE4142-6A54-96B9-6409-1C787800FAA8}"/>
-          </ac:spMkLst>
-        </pc:spChg>
       </pc:sldChg>
     </pc:docChg>
   </pc:docChgLst>
@@ -489,7 +361,7 @@
           <a:p>
             <a:fld id="{9ECA1AE0-D2A3-2446-8EEA-E972E77345DB}" type="datetimeFigureOut">
               <a:rPr lang="es-ES_tradnl" smtClean="0"/>
-              <a:t>19/8/24</a:t>
+              <a:t>27/01/2025</a:t>
             </a:fld>
             <a:endParaRPr lang="es-ES_tradnl"/>
           </a:p>
@@ -689,7 +561,7 @@
           <a:p>
             <a:fld id="{9ECA1AE0-D2A3-2446-8EEA-E972E77345DB}" type="datetimeFigureOut">
               <a:rPr lang="es-ES_tradnl" smtClean="0"/>
-              <a:t>19/8/24</a:t>
+              <a:t>27/01/2025</a:t>
             </a:fld>
             <a:endParaRPr lang="es-ES_tradnl"/>
           </a:p>
@@ -899,7 +771,7 @@
           <a:p>
             <a:fld id="{9ECA1AE0-D2A3-2446-8EEA-E972E77345DB}" type="datetimeFigureOut">
               <a:rPr lang="es-ES_tradnl" smtClean="0"/>
-              <a:t>19/8/24</a:t>
+              <a:t>27/01/2025</a:t>
             </a:fld>
             <a:endParaRPr lang="es-ES_tradnl"/>
           </a:p>
@@ -1099,7 +971,7 @@
           <a:p>
             <a:fld id="{9ECA1AE0-D2A3-2446-8EEA-E972E77345DB}" type="datetimeFigureOut">
               <a:rPr lang="es-ES_tradnl" smtClean="0"/>
-              <a:t>19/8/24</a:t>
+              <a:t>27/01/2025</a:t>
             </a:fld>
             <a:endParaRPr lang="es-ES_tradnl"/>
           </a:p>
@@ -1375,7 +1247,7 @@
           <a:p>
             <a:fld id="{9ECA1AE0-D2A3-2446-8EEA-E972E77345DB}" type="datetimeFigureOut">
               <a:rPr lang="es-ES_tradnl" smtClean="0"/>
-              <a:t>19/8/24</a:t>
+              <a:t>27/01/2025</a:t>
             </a:fld>
             <a:endParaRPr lang="es-ES_tradnl"/>
           </a:p>
@@ -1643,7 +1515,7 @@
           <a:p>
             <a:fld id="{9ECA1AE0-D2A3-2446-8EEA-E972E77345DB}" type="datetimeFigureOut">
               <a:rPr lang="es-ES_tradnl" smtClean="0"/>
-              <a:t>19/8/24</a:t>
+              <a:t>27/01/2025</a:t>
             </a:fld>
             <a:endParaRPr lang="es-ES_tradnl"/>
           </a:p>
@@ -2058,7 +1930,7 @@
           <a:p>
             <a:fld id="{9ECA1AE0-D2A3-2446-8EEA-E972E77345DB}" type="datetimeFigureOut">
               <a:rPr lang="es-ES_tradnl" smtClean="0"/>
-              <a:t>19/8/24</a:t>
+              <a:t>27/01/2025</a:t>
             </a:fld>
             <a:endParaRPr lang="es-ES_tradnl"/>
           </a:p>
@@ -2200,7 +2072,7 @@
           <a:p>
             <a:fld id="{9ECA1AE0-D2A3-2446-8EEA-E972E77345DB}" type="datetimeFigureOut">
               <a:rPr lang="es-ES_tradnl" smtClean="0"/>
-              <a:t>19/8/24</a:t>
+              <a:t>27/01/2025</a:t>
             </a:fld>
             <a:endParaRPr lang="es-ES_tradnl"/>
           </a:p>
@@ -2313,7 +2185,7 @@
           <a:p>
             <a:fld id="{9ECA1AE0-D2A3-2446-8EEA-E972E77345DB}" type="datetimeFigureOut">
               <a:rPr lang="es-ES_tradnl" smtClean="0"/>
-              <a:t>19/8/24</a:t>
+              <a:t>27/01/2025</a:t>
             </a:fld>
             <a:endParaRPr lang="es-ES_tradnl"/>
           </a:p>
@@ -2626,7 +2498,7 @@
           <a:p>
             <a:fld id="{9ECA1AE0-D2A3-2446-8EEA-E972E77345DB}" type="datetimeFigureOut">
               <a:rPr lang="es-ES_tradnl" smtClean="0"/>
-              <a:t>19/8/24</a:t>
+              <a:t>27/01/2025</a:t>
             </a:fld>
             <a:endParaRPr lang="es-ES_tradnl"/>
           </a:p>
@@ -2915,7 +2787,7 @@
           <a:p>
             <a:fld id="{9ECA1AE0-D2A3-2446-8EEA-E972E77345DB}" type="datetimeFigureOut">
               <a:rPr lang="es-ES_tradnl" smtClean="0"/>
-              <a:t>19/8/24</a:t>
+              <a:t>27/01/2025</a:t>
             </a:fld>
             <a:endParaRPr lang="es-ES_tradnl"/>
           </a:p>
@@ -3158,7 +3030,7 @@
           <a:p>
             <a:fld id="{9ECA1AE0-D2A3-2446-8EEA-E972E77345DB}" type="datetimeFigureOut">
               <a:rPr lang="es-ES_tradnl" smtClean="0"/>
-              <a:t>19/8/24</a:t>
+              <a:t>27/01/2025</a:t>
             </a:fld>
             <a:endParaRPr lang="es-ES_tradnl"/>
           </a:p>
@@ -4829,67 +4701,6 @@
           <a:chExt cx="0" cy="0"/>
         </a:xfrm>
       </p:grpSpPr>
-      <p:sp>
-        <p:nvSpPr>
-          <p:cNvPr id="2" name="Título 1">
-            <a:extLst>
-              <a:ext uri="{FF2B5EF4-FFF2-40B4-BE49-F238E27FC236}">
-                <a16:creationId xmlns:a16="http://schemas.microsoft.com/office/drawing/2014/main" id="{B66FD903-9D02-82D8-167A-B7CC666E5357}"/>
-              </a:ext>
-            </a:extLst>
-          </p:cNvPr>
-          <p:cNvSpPr>
-            <a:spLocks noGrp="1"/>
-          </p:cNvSpPr>
-          <p:nvPr>
-            <p:ph type="title"/>
-          </p:nvPr>
-        </p:nvSpPr>
-        <p:spPr/>
-        <p:txBody>
-          <a:bodyPr/>
-          <a:lstStyle/>
-          <a:p>
-            <a:endParaRPr lang="es-ES_tradnl"/>
-          </a:p>
-        </p:txBody>
-      </p:sp>
-      <p:sp>
-        <p:nvSpPr>
-          <p:cNvPr id="3" name="Marcador de contenido 2">
-            <a:extLst>
-              <a:ext uri="{FF2B5EF4-FFF2-40B4-BE49-F238E27FC236}">
-                <a16:creationId xmlns:a16="http://schemas.microsoft.com/office/drawing/2014/main" id="{33EE4142-6A54-96B9-6409-1C787800FAA8}"/>
-              </a:ext>
-            </a:extLst>
-          </p:cNvPr>
-          <p:cNvSpPr>
-            <a:spLocks noGrp="1"/>
-          </p:cNvSpPr>
-          <p:nvPr>
-            <p:ph idx="1"/>
-          </p:nvPr>
-        </p:nvSpPr>
-        <p:spPr/>
-        <p:txBody>
-          <a:bodyPr/>
-          <a:lstStyle/>
-          <a:p>
-            <a:r>
-              <a:rPr lang="es-ES_tradnl" dirty="0"/>
-              <a:t>PERSONA(</a:t>
-            </a:r>
-            <a:r>
-              <a:rPr lang="es-ES_tradnl" dirty="0" err="1"/>
-              <a:t>nif</a:t>
-            </a:r>
-            <a:r>
-              <a:rPr lang="es-ES_tradnl" dirty="0"/>
-              <a:t>, nombre, </a:t>
-            </a:r>
-          </a:p>
-        </p:txBody>
-      </p:sp>
     </p:spTree>
     <p:extLst>
       <p:ext uri="{BB962C8B-B14F-4D97-AF65-F5344CB8AC3E}">

</xml_diff>